<commit_message>
chore(data): refresh weekly/monthly data, run outputs, and deck scripts
Add perturbed weekly/monthly datasets and regenerated run artifacts
(result, result_prev, run_meta, decks, takeaways). Add monthly deck
builder and data perturbation scripts. Update views.py and MEMORY.md.

Co-Authored-By: Claude Opus 4.8 <noreply@anthropic.com>
</commit_message>
<xml_diff>
--- a/output/run_2026-06-04_003/deck.pptx
+++ b/output/run_2026-06-04_003/deck.pptx
@@ -6,7 +6,6 @@
   </p:sldMasterIdLst>
   <p:sldIdLst>
     <p:sldId id="256" r:id="rId7"/>
-    <p:sldId id="257" r:id="rId8"/>
   </p:sldIdLst>
   <p:sldSz cx="12191695" cy="6858000" type="screen4x3"/>
   <p:notesSz cx="6858000" cy="9144000"/>
@@ -143,9 +142,9 @@
           </c:marker>
           <c:cat>
             <c:strRef>
-              <c:f>Sheet1!$A$2:$A$107</c:f>
+              <c:f>Sheet1!$A$2:$A$115</c:f>
               <c:strCache>
-                <c:ptCount val="106"/>
+                <c:ptCount val="114"/>
                 <c:pt idx="0">
                   <c:v>05-03</c:v>
                 </c:pt>
@@ -463,333 +462,381 @@
                 </c:pt>
                 <c:pt idx="105">
                   <c:v>05-08</c:v>
+                </c:pt>
+                <c:pt idx="106">
+                  <c:v>05-15</c:v>
+                </c:pt>
+                <c:pt idx="107">
+                  <c:v>05-22</c:v>
+                </c:pt>
+                <c:pt idx="108">
+                  <c:v>05-29</c:v>
+                </c:pt>
+                <c:pt idx="109">
+                  <c:v>06-05</c:v>
+                </c:pt>
+                <c:pt idx="110">
+                  <c:v>06-12</c:v>
+                </c:pt>
+                <c:pt idx="111">
+                  <c:v>06-19</c:v>
+                </c:pt>
+                <c:pt idx="112">
+                  <c:v>06-26</c:v>
+                </c:pt>
+                <c:pt idx="113">
+                  <c:v>07-03</c:v>
                 </c:pt>
               </c:strCache>
             </c:strRef>
           </c:cat>
           <c:val>
             <c:numRef>
-              <c:f>Sheet1!$B$2:$B$107</c:f>
+              <c:f>Sheet1!$B$2:$B$115</c:f>
               <c:numCache>
                 <c:formatCode>General</c:formatCode>
-                <c:ptCount val="106"/>
+                <c:ptCount val="114"/>
                 <c:pt idx="0">
-                  <c:v>2.612332</c:v>
+                  <c:v>3.2761</c:v>
                 </c:pt>
                 <c:pt idx="1">
-                  <c:v>2.702344</c:v>
+                  <c:v>2.654476</c:v>
                 </c:pt>
                 <c:pt idx="2">
-                  <c:v>2.78221</c:v>
+                  <c:v>3.325078</c:v>
                 </c:pt>
                 <c:pt idx="3">
-                  <c:v>2.782865</c:v>
+                  <c:v>2.296487</c:v>
                 </c:pt>
                 <c:pt idx="4">
-                  <c:v>2.15619</c:v>
+                  <c:v>2.847735</c:v>
                 </c:pt>
                 <c:pt idx="5">
-                  <c:v>2.746877</c:v>
+                  <c:v>3.466003</c:v>
                 </c:pt>
                 <c:pt idx="6">
-                  <c:v>2.713723</c:v>
+                  <c:v>3.383614</c:v>
                 </c:pt>
                 <c:pt idx="7">
-                  <c:v>2.529534</c:v>
+                  <c:v>3.216755</c:v>
                 </c:pt>
                 <c:pt idx="8">
-                  <c:v>2.609349</c:v>
+                  <c:v>2.331576</c:v>
                 </c:pt>
                 <c:pt idx="9">
-                  <c:v>1.809377</c:v>
+                  <c:v>1.708196</c:v>
                 </c:pt>
                 <c:pt idx="10">
-                  <c:v>3.008849</c:v>
+                  <c:v>2.560256</c:v>
                 </c:pt>
                 <c:pt idx="11">
-                  <c:v>2.698503</c:v>
+                  <c:v>2.344949</c:v>
                 </c:pt>
                 <c:pt idx="12">
-                  <c:v>2.653199</c:v>
+                  <c:v>1.672779</c:v>
                 </c:pt>
                 <c:pt idx="13">
-                  <c:v>2.616264</c:v>
+                  <c:v>1.823509</c:v>
                 </c:pt>
                 <c:pt idx="14">
-                  <c:v>2.468523</c:v>
+                  <c:v>2.469521</c:v>
                 </c:pt>
                 <c:pt idx="15">
-                  <c:v>2.538201</c:v>
+                  <c:v>2.248308</c:v>
                 </c:pt>
                 <c:pt idx="16">
-                  <c:v>2.450886</c:v>
+                  <c:v>2.141902</c:v>
                 </c:pt>
                 <c:pt idx="17">
-                  <c:v>2.649313</c:v>
+                  <c:v>2.83951</c:v>
                 </c:pt>
                 <c:pt idx="18">
-                  <c:v>2.414876</c:v>
+                  <c:v>1.730803</c:v>
                 </c:pt>
                 <c:pt idx="19">
-                  <c:v>2.900123</c:v>
+                  <c:v>2.839312</c:v>
                 </c:pt>
                 <c:pt idx="20">
-                  <c:v>2.866679</c:v>
+                  <c:v>2.429921</c:v>
                 </c:pt>
                 <c:pt idx="21">
-                  <c:v>2.819985</c:v>
+                  <c:v>2.007194</c:v>
                 </c:pt>
                 <c:pt idx="22">
-                  <c:v>3.126088</c:v>
+                  <c:v>2.881987</c:v>
                 </c:pt>
                 <c:pt idx="23">
-                  <c:v>2.848107</c:v>
+                  <c:v>2.824312</c:v>
                 </c:pt>
                 <c:pt idx="24">
-                  <c:v>3.1381</c:v>
+                  <c:v>3.088331</c:v>
                 </c:pt>
                 <c:pt idx="25">
-                  <c:v>2.93562</c:v>
+                  <c:v>2.36245</c:v>
                 </c:pt>
                 <c:pt idx="26">
-                  <c:v>4.741307</c:v>
+                  <c:v>3.881197</c:v>
                 </c:pt>
                 <c:pt idx="27">
-                  <c:v>4.812503</c:v>
+                  <c:v>5.085489</c:v>
                 </c:pt>
                 <c:pt idx="28">
-                  <c:v>6.445226</c:v>
+                  <c:v>5.29906</c:v>
                 </c:pt>
                 <c:pt idx="29">
-                  <c:v>6.443161</c:v>
+                  <c:v>5.199284</c:v>
                 </c:pt>
                 <c:pt idx="30">
-                  <c:v>3.850622</c:v>
+                  <c:v>3.669266</c:v>
                 </c:pt>
                 <c:pt idx="31">
-                  <c:v>8.508722</c:v>
+                  <c:v>7.275571</c:v>
                 </c:pt>
                 <c:pt idx="32">
-                  <c:v>15.687294</c:v>
+                  <c:v>13.856834</c:v>
                 </c:pt>
                 <c:pt idx="33">
-                  <c:v>8.934157</c:v>
+                  <c:v>9.651326</c:v>
                 </c:pt>
                 <c:pt idx="34">
-                  <c:v>13.131984</c:v>
+                  <c:v>10.741294</c:v>
                 </c:pt>
                 <c:pt idx="35">
-                  <c:v>20.110836</c:v>
+                  <c:v>16.334964</c:v>
                 </c:pt>
                 <c:pt idx="36">
-                  <c:v>26.894615</c:v>
+                  <c:v>28.697581</c:v>
                 </c:pt>
                 <c:pt idx="37">
-                  <c:v>30.380545</c:v>
+                  <c:v>35.574538</c:v>
                 </c:pt>
                 <c:pt idx="38">
-                  <c:v>31.611349</c:v>
+                  <c:v>33.214742</c:v>
                 </c:pt>
                 <c:pt idx="39">
-                  <c:v>55.597549</c:v>
+                  <c:v>52.677685</c:v>
                 </c:pt>
                 <c:pt idx="40">
-                  <c:v>60.02064</c:v>
+                  <c:v>72.169156</c:v>
                 </c:pt>
                 <c:pt idx="41">
-                  <c:v>63.630046</c:v>
+                  <c:v>54.777754</c:v>
                 </c:pt>
                 <c:pt idx="42">
-                  <c:v>85.133014</c:v>
+                  <c:v>70.648025</c:v>
                 </c:pt>
                 <c:pt idx="43">
-                  <c:v>93.289426</c:v>
+                  <c:v>73.460192</c:v>
                 </c:pt>
                 <c:pt idx="44">
-                  <c:v>141.681555</c:v>
+                  <c:v>172.964966</c:v>
                 </c:pt>
                 <c:pt idx="45">
-                  <c:v>136.408007</c:v>
+                  <c:v>128.130187</c:v>
                 </c:pt>
                 <c:pt idx="46">
-                  <c:v>148.381465</c:v>
+                  <c:v>137.064847</c:v>
                 </c:pt>
                 <c:pt idx="47">
-                  <c:v>159.800669</c:v>
+                  <c:v>123.441635</c:v>
                 </c:pt>
                 <c:pt idx="48">
-                  <c:v>153.521199</c:v>
+                  <c:v>122.065743</c:v>
                 </c:pt>
                 <c:pt idx="49">
-                  <c:v>221.599095</c:v>
+                  <c:v>195.302447</c:v>
                 </c:pt>
                 <c:pt idx="50">
-                  <c:v>211.750973</c:v>
+                  <c:v>250.784443</c:v>
                 </c:pt>
                 <c:pt idx="51">
-                  <c:v>293.869958</c:v>
+                  <c:v>299.986386</c:v>
                 </c:pt>
                 <c:pt idx="52">
-                  <c:v>271.593679</c:v>
+                  <c:v>297.785441</c:v>
                 </c:pt>
                 <c:pt idx="53">
-                  <c:v>328.537725</c:v>
+                  <c:v>350.195866</c:v>
                 </c:pt>
                 <c:pt idx="54">
-                  <c:v>370.178806</c:v>
+                  <c:v>341.202987</c:v>
                 </c:pt>
                 <c:pt idx="55">
-                  <c:v>471.394713</c:v>
+                  <c:v>436.30876</c:v>
                 </c:pt>
                 <c:pt idx="56">
-                  <c:v>384.06305</c:v>
+                  <c:v>287.079868</c:v>
                 </c:pt>
                 <c:pt idx="57">
-                  <c:v>493.561404</c:v>
+                  <c:v>476.645726</c:v>
                 </c:pt>
                 <c:pt idx="58">
-                  <c:v>534.701958</c:v>
+                  <c:v>652.615088</c:v>
                 </c:pt>
                 <c:pt idx="59">
-                  <c:v>605.6644</c:v>
+                  <c:v>545.823808</c:v>
                 </c:pt>
                 <c:pt idx="60">
-                  <c:v>720.101527</c:v>
+                  <c:v>632.602175</c:v>
                 </c:pt>
                 <c:pt idx="61">
-                  <c:v>429.139693</c:v>
+                  <c:v>468.110258</c:v>
                 </c:pt>
                 <c:pt idx="62">
-                  <c:v>730.309522</c:v>
+                  <c:v>754.186652</c:v>
                 </c:pt>
                 <c:pt idx="63">
-                  <c:v>706.457976</c:v>
+                  <c:v>625.665147</c:v>
                 </c:pt>
                 <c:pt idx="64">
-                  <c:v>769.758564</c:v>
+                  <c:v>820.352805</c:v>
                 </c:pt>
                 <c:pt idx="65">
-                  <c:v>752.326198</c:v>
+                  <c:v>898.122197</c:v>
                 </c:pt>
                 <c:pt idx="66">
-                  <c:v>844.072529</c:v>
+                  <c:v>981.565394</c:v>
                 </c:pt>
                 <c:pt idx="67">
-                  <c:v>911.742977</c:v>
+                  <c:v>839.595859</c:v>
                 </c:pt>
                 <c:pt idx="68">
-                  <c:v>989.051921</c:v>
+                  <c:v>1064.310204</c:v>
                 </c:pt>
                 <c:pt idx="69">
-                  <c:v>1046.923918</c:v>
+                  <c:v>1072.353955</c:v>
                 </c:pt>
                 <c:pt idx="70">
-                  <c:v>865.785956</c:v>
+                  <c:v>560.430243</c:v>
                 </c:pt>
                 <c:pt idx="71">
-                  <c:v>1107.241494</c:v>
+                  <c:v>1029.174339</c:v>
                 </c:pt>
                 <c:pt idx="72">
-                  <c:v>1177.814627</c:v>
+                  <c:v>1026.153838</c:v>
                 </c:pt>
                 <c:pt idx="73">
-                  <c:v>1149.275189</c:v>
+                  <c:v>1216.897619</c:v>
                 </c:pt>
                 <c:pt idx="74">
-                  <c:v>1188.668498</c:v>
+                  <c:v>1173.835846</c:v>
                 </c:pt>
                 <c:pt idx="75">
-                  <c:v>1196.056556</c:v>
+                  <c:v>947.131792</c:v>
                 </c:pt>
                 <c:pt idx="76">
-                  <c:v>1332.136658</c:v>
+                  <c:v>1538.457412</c:v>
                 </c:pt>
                 <c:pt idx="77">
-                  <c:v>1342.50119</c:v>
+                  <c:v>1332.499848</c:v>
                 </c:pt>
                 <c:pt idx="78">
-                  <c:v>1396.510944</c:v>
+                  <c:v>1471.457986</c:v>
                 </c:pt>
                 <c:pt idx="79">
-                  <c:v>1497.327143</c:v>
+                  <c:v>1824.01161</c:v>
                 </c:pt>
                 <c:pt idx="80">
-                  <c:v>1611.036366</c:v>
+                  <c:v>1310.981799</c:v>
                 </c:pt>
                 <c:pt idx="81">
-                  <c:v>1711.867565</c:v>
+                  <c:v>1420.930835</c:v>
                 </c:pt>
                 <c:pt idx="82">
-                  <c:v>1213.207282</c:v>
+                  <c:v>1221.21711</c:v>
                 </c:pt>
                 <c:pt idx="83">
-                  <c:v>1919.659971</c:v>
+                  <c:v>1549.763667</c:v>
                 </c:pt>
                 <c:pt idx="84">
-                  <c:v>1934.914688</c:v>
+                  <c:v>1994.870789</c:v>
                 </c:pt>
                 <c:pt idx="85">
-                  <c:v>2020.871073</c:v>
+                  <c:v>2322.145894</c:v>
                 </c:pt>
                 <c:pt idx="86">
-                  <c:v>1349.661994</c:v>
+                  <c:v>1312.630702</c:v>
                 </c:pt>
                 <c:pt idx="87">
-                  <c:v>1565.882949</c:v>
+                  <c:v>1784.193506</c:v>
                 </c:pt>
                 <c:pt idx="88">
-                  <c:v>2289.050671</c:v>
+                  <c:v>2210.01283</c:v>
                 </c:pt>
                 <c:pt idx="89">
-                  <c:v>2164.959166</c:v>
+                  <c:v>2046.976574</c:v>
                 </c:pt>
                 <c:pt idx="90">
-                  <c:v>1748.106984</c:v>
+                  <c:v>1762.936301</c:v>
                 </c:pt>
                 <c:pt idx="91">
-                  <c:v>1774.982863</c:v>
+                  <c:v>1419.5376</c:v>
                 </c:pt>
                 <c:pt idx="92">
-                  <c:v>2431.445212</c:v>
+                  <c:v>2990.551275</c:v>
                 </c:pt>
                 <c:pt idx="93">
-                  <c:v>2366.376774</c:v>
+                  <c:v>3111.095396</c:v>
                 </c:pt>
                 <c:pt idx="94">
-                  <c:v>2190.94118</c:v>
+                  <c:v>2128.80404</c:v>
                 </c:pt>
                 <c:pt idx="95">
-                  <c:v>2343.009056</c:v>
+                  <c:v>2913.115207</c:v>
                 </c:pt>
                 <c:pt idx="96">
-                  <c:v>2540.48585</c:v>
+                  <c:v>2194.477107</c:v>
                 </c:pt>
                 <c:pt idx="97">
-                  <c:v>2462.2867</c:v>
+                  <c:v>2305.831085</c:v>
                 </c:pt>
                 <c:pt idx="98">
-                  <c:v>2428.318927</c:v>
+                  <c:v>1982.348748</c:v>
                 </c:pt>
                 <c:pt idx="99">
-                  <c:v>2770.962167</c:v>
+                  <c:v>2559.50345</c:v>
                 </c:pt>
                 <c:pt idx="100">
-                  <c:v>2719.39605</c:v>
+                  <c:v>2047.495579</c:v>
                 </c:pt>
                 <c:pt idx="101">
-                  <c:v>2565.06414</c:v>
+                  <c:v>1987.786485</c:v>
                 </c:pt>
                 <c:pt idx="102">
-                  <c:v>2591.39877</c:v>
+                  <c:v>2956.534443</c:v>
                 </c:pt>
                 <c:pt idx="103">
-                  <c:v>2781.238172</c:v>
+                  <c:v>3044.645466</c:v>
                 </c:pt>
                 <c:pt idx="104">
-                  <c:v>3026.023211</c:v>
+                  <c:v>2831.508049</c:v>
                 </c:pt>
                 <c:pt idx="105">
-                  <c:v>3120.916383</c:v>
+                  <c:v>3580.891303</c:v>
+                </c:pt>
+                <c:pt idx="106">
+                  <c:v>3742.423584</c:v>
+                </c:pt>
+                <c:pt idx="107">
+                  <c:v>4071.408679</c:v>
+                </c:pt>
+                <c:pt idx="108">
+                  <c:v>2678.415178</c:v>
+                </c:pt>
+                <c:pt idx="109">
+                  <c:v>4054.680471</c:v>
+                </c:pt>
+                <c:pt idx="110">
+                  <c:v>4138.123481</c:v>
+                </c:pt>
+                <c:pt idx="111">
+                  <c:v>4133.085272</c:v>
+                </c:pt>
+                <c:pt idx="112">
+                  <c:v>3659.647996</c:v>
+                </c:pt>
+                <c:pt idx="113">
+                  <c:v>3769.794164</c:v>
                 </c:pt>
               </c:numCache>
             </c:numRef>
@@ -822,9 +869,9 @@
           </c:marker>
           <c:cat>
             <c:strRef>
-              <c:f>Sheet1!$A$2:$A$107</c:f>
+              <c:f>Sheet1!$A$2:$A$115</c:f>
               <c:strCache>
-                <c:ptCount val="106"/>
+                <c:ptCount val="114"/>
                 <c:pt idx="0">
                   <c:v>05-03</c:v>
                 </c:pt>
@@ -1142,333 +1189,381 @@
                 </c:pt>
                 <c:pt idx="105">
                   <c:v>05-08</c:v>
+                </c:pt>
+                <c:pt idx="106">
+                  <c:v>05-15</c:v>
+                </c:pt>
+                <c:pt idx="107">
+                  <c:v>05-22</c:v>
+                </c:pt>
+                <c:pt idx="108">
+                  <c:v>05-29</c:v>
+                </c:pt>
+                <c:pt idx="109">
+                  <c:v>06-05</c:v>
+                </c:pt>
+                <c:pt idx="110">
+                  <c:v>06-12</c:v>
+                </c:pt>
+                <c:pt idx="111">
+                  <c:v>06-19</c:v>
+                </c:pt>
+                <c:pt idx="112">
+                  <c:v>06-26</c:v>
+                </c:pt>
+                <c:pt idx="113">
+                  <c:v>07-03</c:v>
                 </c:pt>
               </c:strCache>
             </c:strRef>
           </c:cat>
           <c:val>
             <c:numRef>
-              <c:f>Sheet1!$C$2:$C$107</c:f>
+              <c:f>Sheet1!$C$2:$C$115</c:f>
               <c:numCache>
                 <c:formatCode>General</c:formatCode>
-                <c:ptCount val="106"/>
+                <c:ptCount val="114"/>
                 <c:pt idx="0">
-                  <c:v>5.290623</c:v>
+                  <c:v>5.769896</c:v>
                 </c:pt>
                 <c:pt idx="1">
-                  <c:v>5.472922</c:v>
+                  <c:v>4.675087</c:v>
                 </c:pt>
                 <c:pt idx="2">
-                  <c:v>5.63467</c:v>
+                  <c:v>5.856157</c:v>
                 </c:pt>
                 <c:pt idx="3">
-                  <c:v>5.635995</c:v>
+                  <c:v>4.044593</c:v>
                 </c:pt>
                 <c:pt idx="4">
-                  <c:v>4.366822</c:v>
+                  <c:v>5.015456</c:v>
                 </c:pt>
                 <c:pt idx="5">
-                  <c:v>5.554632</c:v>
+                  <c:v>5.925582</c:v>
                 </c:pt>
                 <c:pt idx="6">
-                  <c:v>5.487589</c:v>
+                  <c:v>5.784727</c:v>
                 </c:pt>
                 <c:pt idx="7">
-                  <c:v>5.115128</c:v>
+                  <c:v>5.499459</c:v>
                 </c:pt>
                 <c:pt idx="8">
-                  <c:v>5.276528</c:v>
+                  <c:v>3.986132</c:v>
                 </c:pt>
                 <c:pt idx="9">
-                  <c:v>3.623258</c:v>
+                  <c:v>4.436085</c:v>
                 </c:pt>
                 <c:pt idx="10">
-                  <c:v>6.025185</c:v>
+                  <c:v>6.648837</c:v>
                 </c:pt>
                 <c:pt idx="11">
-                  <c:v>5.40372</c:v>
+                  <c:v>6.089697</c:v>
                 </c:pt>
                 <c:pt idx="12">
-                  <c:v>5.313</c:v>
+                  <c:v>4.344109</c:v>
                 </c:pt>
                 <c:pt idx="13">
-                  <c:v>5.086316</c:v>
+                  <c:v>4.296293</c:v>
                 </c:pt>
                 <c:pt idx="14">
-                  <c:v>4.79909</c:v>
+                  <c:v>5.818333</c:v>
                 </c:pt>
                 <c:pt idx="15">
-                  <c:v>4.934553</c:v>
+                  <c:v>5.297142</c:v>
                 </c:pt>
                 <c:pt idx="16">
-                  <c:v>4.764803</c:v>
+                  <c:v>5.046445</c:v>
                 </c:pt>
                 <c:pt idx="17">
-                  <c:v>5.150567</c:v>
+                  <c:v>6.690048</c:v>
                 </c:pt>
                 <c:pt idx="18">
-                  <c:v>4.520566</c:v>
+                  <c:v>3.984683</c:v>
                 </c:pt>
                 <c:pt idx="19">
-                  <c:v>5.428932</c:v>
+                  <c:v>6.53671</c:v>
                 </c:pt>
                 <c:pt idx="20">
-                  <c:v>5.366327</c:v>
+                  <c:v>5.594204</c:v>
                 </c:pt>
                 <c:pt idx="21">
-                  <c:v>5.278915</c:v>
+                  <c:v>4.620994</c:v>
                 </c:pt>
                 <c:pt idx="22">
-                  <c:v>5.1686</c:v>
+                  <c:v>4.418608</c:v>
                 </c:pt>
                 <c:pt idx="23">
-                  <c:v>4.708993</c:v>
+                  <c:v>4.330181</c:v>
                 </c:pt>
                 <c:pt idx="24">
-                  <c:v>5.18846</c:v>
+                  <c:v>4.734971</c:v>
                 </c:pt>
                 <c:pt idx="25">
-                  <c:v>4.853683</c:v>
+                  <c:v>3.622063</c:v>
                 </c:pt>
                 <c:pt idx="26">
-                  <c:v>4.842223</c:v>
+                  <c:v>4.039634</c:v>
                 </c:pt>
                 <c:pt idx="27">
-                  <c:v>4.914933</c:v>
+                  <c:v>5.293087</c:v>
                 </c:pt>
                 <c:pt idx="28">
-                  <c:v>6.582409</c:v>
+                  <c:v>5.515376</c:v>
                 </c:pt>
                 <c:pt idx="29">
-                  <c:v>6.580299</c:v>
+                  <c:v>5.411527</c:v>
                 </c:pt>
                 <c:pt idx="30">
-                  <c:v>3.932579</c:v>
+                  <c:v>3.819051</c:v>
                 </c:pt>
                 <c:pt idx="31">
-                  <c:v>3.968704</c:v>
+                  <c:v>2.817271</c:v>
                 </c:pt>
                 <c:pt idx="32">
-                  <c:v>7.316988</c:v>
+                  <c:v>5.36569</c:v>
                 </c:pt>
                 <c:pt idx="33">
-                  <c:v>4.167138</c:v>
+                  <c:v>3.737219</c:v>
                 </c:pt>
                 <c:pt idx="34">
-                  <c:v>6.125121</c:v>
+                  <c:v>4.15928</c:v>
                 </c:pt>
                 <c:pt idx="35">
-                  <c:v>3.311256</c:v>
+                  <c:v>3.511933</c:v>
                 </c:pt>
                 <c:pt idx="36">
-                  <c:v>4.428208</c:v>
+                  <c:v>6.169831</c:v>
                 </c:pt>
                 <c:pt idx="37">
-                  <c:v>5.002168</c:v>
+                  <c:v>7.648341</c:v>
                 </c:pt>
                 <c:pt idx="38">
-                  <c:v>5.20482</c:v>
+                  <c:v>7.140997</c:v>
                 </c:pt>
                 <c:pt idx="39">
-                  <c:v>9.154156</c:v>
+                  <c:v>11.325429</c:v>
                 </c:pt>
                 <c:pt idx="40">
-                  <c:v>6.134223</c:v>
+                  <c:v>5.621278</c:v>
                 </c:pt>
                 <c:pt idx="41">
-                  <c:v>6.503111</c:v>
+                  <c:v>4.266656</c:v>
                 </c:pt>
                 <c:pt idx="42">
-                  <c:v>8.700755</c:v>
+                  <c:v>5.502797</c:v>
                 </c:pt>
                 <c:pt idx="43">
-                  <c:v>9.534356</c:v>
+                  <c:v>5.721837</c:v>
                 </c:pt>
                 <c:pt idx="44">
-                  <c:v>9.624129</c:v>
+                  <c:v>14.198474</c:v>
                 </c:pt>
                 <c:pt idx="45">
-                  <c:v>9.265908</c:v>
+                  <c:v>10.518044</c:v>
                 </c:pt>
                 <c:pt idx="46">
-                  <c:v>10.07924</c:v>
+                  <c:v>11.251479</c:v>
                 </c:pt>
                 <c:pt idx="47">
-                  <c:v>10.854922</c:v>
+                  <c:v>10.133166</c:v>
                 </c:pt>
                 <c:pt idx="48">
-                  <c:v>14.374245</c:v>
+                  <c:v>11.595897</c:v>
                 </c:pt>
                 <c:pt idx="49">
-                  <c:v>20.748403</c:v>
+                  <c:v>18.553175</c:v>
                 </c:pt>
                 <c:pt idx="50">
-                  <c:v>19.82632</c:v>
+                  <c:v>23.823806</c:v>
                 </c:pt>
                 <c:pt idx="51">
-                  <c:v>27.51515</c:v>
+                  <c:v>28.49785</c:v>
                 </c:pt>
                 <c:pt idx="52">
-                  <c:v>52.947857</c:v>
+                  <c:v>60.671994</c:v>
                 </c:pt>
                 <c:pt idx="53">
-                  <c:v>64.049239</c:v>
+                  <c:v>71.350303</c:v>
                 </c:pt>
                 <c:pt idx="54">
-                  <c:v>72.167271</c:v>
+                  <c:v>69.518058</c:v>
                 </c:pt>
                 <c:pt idx="55">
-                  <c:v>91.899561</c:v>
+                  <c:v>88.895287</c:v>
                 </c:pt>
                 <c:pt idx="56">
-                  <c:v>74.874038</c:v>
+                  <c:v>58.490798</c:v>
                 </c:pt>
                 <c:pt idx="57">
-                  <c:v>194.483046</c:v>
+                  <c:v>196.839737</c:v>
                 </c:pt>
                 <c:pt idx="58">
-                  <c:v>210.694079</c:v>
+                  <c:v>269.509565</c:v>
                 </c:pt>
                 <c:pt idx="59">
-                  <c:v>238.656136</c:v>
+                  <c:v>225.408115</c:v>
                 </c:pt>
                 <c:pt idx="60">
-                  <c:v>283.748968</c:v>
+                  <c:v>261.24486</c:v>
                 </c:pt>
                 <c:pt idx="61">
-                  <c:v>310.52569</c:v>
+                  <c:v>299.466535</c:v>
                 </c:pt>
                 <c:pt idx="62">
-                  <c:v>528.452325</c:v>
+                  <c:v>482.47963</c:v>
                 </c:pt>
                 <c:pt idx="63">
-                  <c:v>511.193335</c:v>
+                  <c:v>400.259919</c:v>
                 </c:pt>
                 <c:pt idx="64">
-                  <c:v>556.997671</c:v>
+                  <c:v>524.808437</c:v>
                 </c:pt>
                 <c:pt idx="65">
-                  <c:v>651.555866</c:v>
+                  <c:v>697.018451</c:v>
                 </c:pt>
                 <c:pt idx="66">
-                  <c:v>731.013236</c:v>
+                  <c:v>761.777398</c:v>
                 </c:pt>
                 <c:pt idx="67">
-                  <c:v>789.619566</c:v>
+                  <c:v>651.597084</c:v>
                 </c:pt>
                 <c:pt idx="68">
-                  <c:v>856.573363</c:v>
+                  <c:v>825.994338</c:v>
                 </c:pt>
                 <c:pt idx="69">
-                  <c:v>906.693695</c:v>
+                  <c:v>832.236966</c:v>
                 </c:pt>
                 <c:pt idx="70">
-                  <c:v>799.328872</c:v>
+                  <c:v>690.824703</c:v>
                 </c:pt>
                 <c:pt idx="71">
-                  <c:v>1022.250463</c:v>
+                  <c:v>1268.630781</c:v>
                 </c:pt>
                 <c:pt idx="72">
-                  <c:v>1087.406455</c:v>
+                  <c:v>1264.907505</c:v>
                 </c:pt>
                 <c:pt idx="73">
-                  <c:v>1061.057682</c:v>
+                  <c:v>1500.031354</c:v>
                 </c:pt>
                 <c:pt idx="74">
-                  <c:v>1228.424547</c:v>
+                  <c:v>1115.862472</c:v>
                 </c:pt>
                 <c:pt idx="75">
-                  <c:v>1236.059704</c:v>
+                  <c:v>900.354872</c:v>
                 </c:pt>
                 <c:pt idx="76">
-                  <c:v>1376.691123</c:v>
+                  <c:v>1462.476117</c:v>
                 </c:pt>
                 <c:pt idx="77">
-                  <c:v>1387.402305</c:v>
+                  <c:v>1266.690381</c:v>
                 </c:pt>
                 <c:pt idx="78">
-                  <c:v>1443.218462</c:v>
+                  <c:v>1398.785658</c:v>
                 </c:pt>
                 <c:pt idx="79">
-                  <c:v>1654.789059</c:v>
+                  <c:v>1839.031666</c:v>
                 </c:pt>
                 <c:pt idx="80">
-                  <c:v>1780.456171</c:v>
+                  <c:v>1321.777245</c:v>
                 </c:pt>
                 <c:pt idx="81">
-                  <c:v>1891.89098</c:v>
+                  <c:v>1432.63167</c:v>
                 </c:pt>
                 <c:pt idx="82">
-                  <c:v>1340.790586</c:v>
+                  <c:v>1231.273377</c:v>
                 </c:pt>
                 <c:pt idx="83">
-                  <c:v>2157.619854</c:v>
+                  <c:v>1763.178325</c:v>
                 </c:pt>
                 <c:pt idx="84">
-                  <c:v>2174.765537</c:v>
+                  <c:v>2269.580203</c:v>
                 </c:pt>
                 <c:pt idx="85">
-                  <c:v>2271.377023</c:v>
+                  <c:v>2641.923666</c:v>
                 </c:pt>
                 <c:pt idx="86">
-                  <c:v>1516.965275</c:v>
+                  <c:v>1493.390284</c:v>
                 </c:pt>
                 <c:pt idx="87">
-                  <c:v>1769.179053</c:v>
+                  <c:v>2274.762178</c:v>
                 </c:pt>
                 <c:pt idx="88">
-                  <c:v>2586.234494</c:v>
+                  <c:v>2817.661639</c:v>
                 </c:pt>
                 <c:pt idx="89">
-                  <c:v>2446.032385</c:v>
+                  <c:v>2609.798138</c:v>
                 </c:pt>
                 <c:pt idx="90">
-                  <c:v>1975.060944</c:v>
+                  <c:v>2247.660249</c:v>
                 </c:pt>
                 <c:pt idx="91">
-                  <c:v>2005.426076</c:v>
+                  <c:v>1809.843177</c:v>
                 </c:pt>
                 <c:pt idx="92">
-                  <c:v>2869.197054</c:v>
+                  <c:v>2932.44709</c:v>
                 </c:pt>
                 <c:pt idx="93">
-                  <c:v>2792.413842</c:v>
+                  <c:v>3050.649128</c:v>
                 </c:pt>
                 <c:pt idx="94">
-                  <c:v>2585.393226</c:v>
+                  <c:v>2087.442962</c:v>
                 </c:pt>
                 <c:pt idx="95">
-                  <c:v>2764.839053</c:v>
+                  <c:v>2856.515547</c:v>
                 </c:pt>
                 <c:pt idx="96">
-                  <c:v>3112.042916</c:v>
+                  <c:v>3569.920241</c:v>
                 </c:pt>
                 <c:pt idx="97">
-                  <c:v>3016.250565</c:v>
+                  <c:v>3751.068095</c:v>
                 </c:pt>
                 <c:pt idx="98">
-                  <c:v>2974.640742</c:v>
+                  <c:v>3224.835153</c:v>
                 </c:pt>
                 <c:pt idx="99">
-                  <c:v>3394.371663</c:v>
+                  <c:v>4163.735927</c:v>
                 </c:pt>
                 <c:pt idx="100">
-                  <c:v>3402.740504</c:v>
+                  <c:v>2907.349687</c:v>
                 </c:pt>
                 <c:pt idx="101">
-                  <c:v>3209.627243</c:v>
+                  <c:v>2822.565515</c:v>
                 </c:pt>
                 <c:pt idx="102">
-                  <c:v>3242.579381</c:v>
+                  <c:v>4198.143124</c:v>
                 </c:pt>
                 <c:pt idx="103">
-                  <c:v>3480.122648</c:v>
+                  <c:v>4323.25673</c:v>
                 </c:pt>
                 <c:pt idx="104">
-                  <c:v>3786.418588</c:v>
+                  <c:v>3165.417124</c:v>
                 </c:pt>
                 <c:pt idx="105">
-                  <c:v>3905.157025</c:v>
+                  <c:v>4003.17232</c:v>
+                </c:pt>
+                <c:pt idx="106">
+                  <c:v>4183.753495</c:v>
+                </c:pt>
+                <c:pt idx="107">
+                  <c:v>4551.534562</c:v>
+                </c:pt>
+                <c:pt idx="108">
+                  <c:v>2994.270588</c:v>
+                </c:pt>
+                <c:pt idx="109">
+                  <c:v>5066.984656</c:v>
+                </c:pt>
+                <c:pt idx="110">
+                  <c:v>5171.260308</c:v>
+                </c:pt>
+                <c:pt idx="111">
+                  <c:v>5164.964244</c:v>
+                </c:pt>
+                <c:pt idx="112">
+                  <c:v>4573.32714</c:v>
+                </c:pt>
+                <c:pt idx="113">
+                  <c:v>4710.972744</c:v>
                 </c:pt>
               </c:numCache>
             </c:numRef>
@@ -1517,8 +1612,8 @@
         <c:lblAlgn val="ctr"/>
         <c:lblOffset val="100"/>
         <c:noMultiLvlLbl val="0"/>
-        <c:tickLblSkip val="11"/>
-        <c:tickMarkSkip val="11"/>
+        <c:tickLblSkip val="12"/>
+        <c:tickMarkSkip val="12"/>
       </c:catAx>
       <c:valAx>
         <c:axId val="2140495176"/>
@@ -4586,316 +4681,6 @@
             <a:avLst/>
           </a:prstGeom>
           <a:solidFill>
-            <a:srgbClr val="071D49"/>
-          </a:solidFill>
-          <a:ln>
-            <a:noFill/>
-          </a:ln>
-          <a:effectLst/>
-        </p:spPr>
-        <p:style>
-          <a:lnRef idx="1">
-            <a:schemeClr val="accent1"/>
-          </a:lnRef>
-          <a:fillRef idx="3">
-            <a:schemeClr val="accent1"/>
-          </a:fillRef>
-          <a:effectRef idx="2">
-            <a:schemeClr val="accent1"/>
-          </a:effectRef>
-          <a:fontRef idx="minor">
-            <a:schemeClr val="lt1"/>
-          </a:fontRef>
-        </p:style>
-        <p:txBody>
-          <a:bodyPr rtlCol="0" anchor="ctr"/>
-          <a:lstStyle/>
-          <a:p>
-            <a:pPr algn="ctr"/>
-          </a:p>
-        </p:txBody>
-      </p:sp>
-      <p:sp>
-        <p:nvSpPr>
-          <p:cNvPr id="3" name="Rectangle 2"/>
-          <p:cNvSpPr/>
-          <p:nvPr/>
-        </p:nvSpPr>
-        <p:spPr>
-          <a:xfrm>
-            <a:off x="411480" y="2331720"/>
-            <a:ext cx="822960" cy="82296"/>
-          </a:xfrm>
-          <a:prstGeom prst="rect">
-            <a:avLst/>
-          </a:prstGeom>
-          <a:solidFill>
-            <a:srgbClr val="E40D62"/>
-          </a:solidFill>
-          <a:ln>
-            <a:noFill/>
-          </a:ln>
-          <a:effectLst/>
-        </p:spPr>
-        <p:style>
-          <a:lnRef idx="1">
-            <a:schemeClr val="accent1"/>
-          </a:lnRef>
-          <a:fillRef idx="3">
-            <a:schemeClr val="accent1"/>
-          </a:fillRef>
-          <a:effectRef idx="2">
-            <a:schemeClr val="accent1"/>
-          </a:effectRef>
-          <a:fontRef idx="minor">
-            <a:schemeClr val="lt1"/>
-          </a:fontRef>
-        </p:style>
-        <p:txBody>
-          <a:bodyPr rtlCol="0" anchor="ctr"/>
-          <a:lstStyle/>
-          <a:p>
-            <a:pPr algn="ctr"/>
-          </a:p>
-        </p:txBody>
-      </p:sp>
-      <p:sp>
-        <p:nvSpPr>
-          <p:cNvPr id="4" name="TextBox 3"/>
-          <p:cNvSpPr txBox="1"/>
-          <p:nvPr/>
-        </p:nvSpPr>
-        <p:spPr>
-          <a:xfrm>
-            <a:off x="411480" y="1463040"/>
-            <a:ext cx="7315200" cy="365760"/>
-          </a:xfrm>
-          <a:prstGeom prst="rect">
-            <a:avLst/>
-          </a:prstGeom>
-          <a:noFill/>
-        </p:spPr>
-        <p:txBody>
-          <a:bodyPr wrap="square" anchor="t" lIns="0" rIns="0" tIns="0" bIns="0">
-            <a:spAutoFit/>
-          </a:bodyPr>
-          <a:lstStyle/>
-          <a:p>
-            <a:pPr algn="l">
-              <a:lnSpc>
-                <a:spcPct val="100000"/>
-              </a:lnSpc>
-            </a:pPr>
-            <a:r>
-              <a:rPr sz="1400" b="1" i="0">
-                <a:solidFill>
-                  <a:srgbClr val="07B2AC"/>
-                </a:solidFill>
-                <a:latin typeface="Montserrat Medium"/>
-              </a:rPr>
-              <a:t>TREMFYA · IBD MARKET</a:t>
-            </a:r>
-          </a:p>
-        </p:txBody>
-      </p:sp>
-      <p:sp>
-        <p:nvSpPr>
-          <p:cNvPr id="5" name="TextBox 4"/>
-          <p:cNvSpPr txBox="1"/>
-          <p:nvPr/>
-        </p:nvSpPr>
-        <p:spPr>
-          <a:xfrm>
-            <a:off x="411480" y="2560320"/>
-            <a:ext cx="10515600" cy="2011680"/>
-          </a:xfrm>
-          <a:prstGeom prst="rect">
-            <a:avLst/>
-          </a:prstGeom>
-          <a:noFill/>
-        </p:spPr>
-        <p:txBody>
-          <a:bodyPr wrap="square" anchor="t" lIns="0" rIns="0" tIns="0" bIns="0">
-            <a:spAutoFit/>
-          </a:bodyPr>
-          <a:lstStyle/>
-          <a:p>
-            <a:pPr algn="l">
-              <a:lnSpc>
-                <a:spcPct val="100000"/>
-              </a:lnSpc>
-            </a:pPr>
-            <a:r>
-              <a:rPr sz="4600" b="1" i="0">
-                <a:solidFill>
-                  <a:srgbClr val="FFFFFF"/>
-                </a:solidFill>
-                <a:latin typeface="Montserrat Medium"/>
-              </a:rPr>
-              <a:t>Tremfya SQ IBD Performance</a:t>
-            </a:r>
-          </a:p>
-        </p:txBody>
-      </p:sp>
-      <p:sp>
-        <p:nvSpPr>
-          <p:cNvPr id="6" name="TextBox 5"/>
-          <p:cNvSpPr txBox="1"/>
-          <p:nvPr/>
-        </p:nvSpPr>
-        <p:spPr>
-          <a:xfrm>
-            <a:off x="429768" y="4114800"/>
-            <a:ext cx="10058400" cy="731520"/>
-          </a:xfrm>
-          <a:prstGeom prst="rect">
-            <a:avLst/>
-          </a:prstGeom>
-          <a:noFill/>
-        </p:spPr>
-        <p:txBody>
-          <a:bodyPr wrap="square" anchor="t" lIns="0" rIns="0" tIns="0" bIns="0">
-            <a:spAutoFit/>
-          </a:bodyPr>
-          <a:lstStyle/>
-          <a:p>
-            <a:pPr algn="l">
-              <a:lnSpc>
-                <a:spcPct val="100000"/>
-              </a:lnSpc>
-            </a:pPr>
-            <a:r>
-              <a:rPr sz="1800" b="0" i="1">
-                <a:solidFill>
-                  <a:srgbClr val="D9DEE8"/>
-                </a:solidFill>
-                <a:latin typeface="Roboto"/>
-              </a:rPr>
-              <a:t>Weekly TRx split by indication (UC / CD), full series</a:t>
-            </a:r>
-          </a:p>
-        </p:txBody>
-      </p:sp>
-      <p:sp>
-        <p:nvSpPr>
-          <p:cNvPr id="7" name="TextBox 6"/>
-          <p:cNvSpPr txBox="1"/>
-          <p:nvPr/>
-        </p:nvSpPr>
-        <p:spPr>
-          <a:xfrm>
-            <a:off x="411480" y="6437376"/>
-            <a:ext cx="3657600" cy="274320"/>
-          </a:xfrm>
-          <a:prstGeom prst="rect">
-            <a:avLst/>
-          </a:prstGeom>
-          <a:noFill/>
-        </p:spPr>
-        <p:txBody>
-          <a:bodyPr wrap="square" anchor="t" lIns="0" rIns="0" tIns="0" bIns="0">
-            <a:spAutoFit/>
-          </a:bodyPr>
-          <a:lstStyle/>
-          <a:p>
-            <a:pPr algn="l">
-              <a:lnSpc>
-                <a:spcPct val="100000"/>
-              </a:lnSpc>
-            </a:pPr>
-            <a:r>
-              <a:rPr sz="1100" b="1" i="0">
-                <a:solidFill>
-                  <a:srgbClr val="E40D62"/>
-                </a:solidFill>
-                <a:latin typeface="Montserrat Medium"/>
-              </a:rPr>
-              <a:t>▶ </a:t>
-            </a:r>
-            <a:r>
-              <a:rPr sz="1100" b="1" i="0">
-                <a:solidFill>
-                  <a:srgbClr val="FFFFFF"/>
-                </a:solidFill>
-                <a:latin typeface="Montserrat Medium"/>
-              </a:rPr>
-              <a:t>DataZymes</a:t>
-            </a:r>
-          </a:p>
-        </p:txBody>
-      </p:sp>
-      <p:sp>
-        <p:nvSpPr>
-          <p:cNvPr id="8" name="TextBox 7"/>
-          <p:cNvSpPr txBox="1"/>
-          <p:nvPr/>
-        </p:nvSpPr>
-        <p:spPr>
-          <a:xfrm>
-            <a:off x="11338560" y="6437376"/>
-            <a:ext cx="457200" cy="274320"/>
-          </a:xfrm>
-          <a:prstGeom prst="rect">
-            <a:avLst/>
-          </a:prstGeom>
-          <a:noFill/>
-        </p:spPr>
-        <p:txBody>
-          <a:bodyPr wrap="square" anchor="t" lIns="0" rIns="0" tIns="0" bIns="0">
-            <a:spAutoFit/>
-          </a:bodyPr>
-          <a:lstStyle/>
-          <a:p>
-            <a:pPr algn="r">
-              <a:lnSpc>
-                <a:spcPct val="100000"/>
-              </a:lnSpc>
-            </a:pPr>
-            <a:r>
-              <a:rPr sz="1100" b="0" i="0">
-                <a:solidFill>
-                  <a:srgbClr val="FFFFFF"/>
-                </a:solidFill>
-                <a:latin typeface="Roboto"/>
-              </a:rPr>
-              <a:t>9</a:t>
-            </a:r>
-          </a:p>
-        </p:txBody>
-      </p:sp>
-    </p:spTree>
-  </p:cSld>
-  <p:clrMapOvr>
-    <a:masterClrMapping/>
-  </p:clrMapOvr>
-</p:sld>
-</file>
-
-<file path=ppt/slides/slide2.xml><?xml version="1.0" encoding="utf-8"?>
-<p:sld xmlns:a="http://schemas.openxmlformats.org/drawingml/2006/main" xmlns:p="http://schemas.openxmlformats.org/presentationml/2006/main" xmlns:r="http://schemas.openxmlformats.org/officeDocument/2006/relationships">
-  <p:cSld>
-    <p:spTree>
-      <p:nvGrpSpPr>
-        <p:cNvPr id="1" name=""/>
-        <p:cNvGrpSpPr/>
-        <p:nvPr/>
-      </p:nvGrpSpPr>
-      <p:grpSpPr/>
-      <p:sp>
-        <p:nvSpPr>
-          <p:cNvPr id="2" name="Rectangle 1"/>
-          <p:cNvSpPr/>
-          <p:nvPr/>
-        </p:nvSpPr>
-        <p:spPr>
-          <a:xfrm>
-            <a:off x="0" y="0"/>
-            <a:ext cx="12191695" cy="6858000"/>
-          </a:xfrm>
-          <a:prstGeom prst="rect">
-            <a:avLst/>
-          </a:prstGeom>
-          <a:solidFill>
             <a:srgbClr val="FFFFFF"/>
           </a:solidFill>
           <a:ln>
@@ -5120,7 +4905,7 @@
                 </a:solidFill>
                 <a:latin typeface="Roboto"/>
               </a:rPr>
-              <a:t>Tremfya's weekly IBD volume has scaled from ~8 to ~7,026 TRx since May 2024. Within IBD, Crohn's pulled level in Oct 2025 and now leads ulcerative colitis.</a:t>
+              <a:t>Tremfya's weekly IBD volume has scaled from ~9 to ~8,481 TRx since May 2024. Within IBD, Crohn's pulled level in Mar 2026 and now leads ulcerative colitis.</a:t>
             </a:r>
           </a:p>
         </p:txBody>
@@ -5294,7 +5079,7 @@
                 </a:solidFill>
                 <a:latin typeface="Roboto"/>
               </a:rPr>
-              <a:t>CD ~3,905 vs UC ~3,121 TRx in the latest week (05-08).</a:t>
+              <a:t>CD ~4,711 vs UC ~3,770 TRx in the latest week (07-03).</a:t>
             </a:r>
           </a:p>
         </p:txBody>
@@ -5372,7 +5157,7 @@
                 </a:solidFill>
                 <a:latin typeface="Montserrat Medium"/>
               </a:rPr>
-              <a:t>Crossover · Oct 2025</a:t>
+              <a:t>Crossover · Mar 2026</a:t>
             </a:r>
           </a:p>
         </p:txBody>
@@ -5489,7 +5274,7 @@
                 </a:solidFill>
                 <a:latin typeface="Montserrat Medium"/>
               </a:rPr>
-              <a:t>~889x ramp</a:t>
+              <a:t>~938x ramp</a:t>
             </a:r>
           </a:p>
         </p:txBody>
@@ -5528,7 +5313,7 @@
                 </a:solidFill>
                 <a:latin typeface="Roboto"/>
               </a:rPr>
-              <a:t>Tremfya's IBD volume rose from ~8 to ~7,026 weekly TRx.</a:t>
+              <a:t>Tremfya's IBD volume rose from ~9 to ~8,481 weekly TRx.</a:t>
             </a:r>
           </a:p>
         </p:txBody>
@@ -5751,7 +5536,7 @@
                 </a:solidFill>
                 <a:latin typeface="Roboto"/>
               </a:rPr>
-              <a:t>10</a:t>
+              <a:t>1</a:t>
             </a:r>
           </a:p>
         </p:txBody>

</xml_diff>